<commit_message>
Redesign the comparison screen, warm the app up before it takes traffic, and rewrite the README, slides and pitch
The screen is now a left-and-right comparison in plain boxes: each machine's power through
the day, the machine ENACT picks, and for each copy the time on dirty power, where it ran,
its requests, and what its own Application Controller check says.

GreenCharge calls its own endpoints before reporting ready and runs with a two-core limit:
a run on a busy laptop lost 4 of 529 requests to the cold new copy. Three replays and a
30-move test since then lost none; every run is in evidence/.

The scene rewrites every node's label on a rewind and waits for the operator to settle on
the greener node, so both copies start on the same machine each time.
</commit_message>
<xml_diff>
--- a/docs/slides/Sunflower-VelesHack.pptx
+++ b/docs/slides/Sunflower-VelesHack.pptx
@@ -5383,7 +5383,7 @@
                 <a:cs typeface="Roboto"/>
                 <a:sym typeface="Roboto"/>
               </a:rPr>
-              <a:t>GreenCharge tells drivers where the clean power is. Sunflower makes GreenCharge go there itself.</a:t>
+              <a:t>Moves a running app to the computer with the cleanest power, without losing a request.</a:t>
             </a:r>
           </a:p>
           <a:p>
@@ -5409,7 +5409,7 @@
                 <a:cs typeface="Roboto"/>
                 <a:sym typeface="Roboto"/>
               </a:rPr>
-              <a:t>Challenge 3 · ENACT, Kubernetes Dynamic Adaptation</a:t>
+              <a:t>Challenge 3, ENACT: Kubernetes Dynamic Adaptation</a:t>
             </a:r>
           </a:p>
         </p:txBody>
@@ -5612,7 +5612,7 @@
                 <a:cs typeface="Roboto"/>
                 <a:sym typeface="Roboto"/>
               </a:rPr>
-              <a:t>docs/demo. It is the measured data, unedited.</a:t>
+              <a:t>docs/demo, drawn from the measured data, unedited.</a:t>
             </a:r>
           </a:p>
           <a:p>
@@ -5636,7 +5636,7 @@
                 <a:cs typeface="Roboto"/>
                 <a:sym typeface="Roboto"/>
               </a:rPr>
-              <a:t>Everything measured is in the repo: </a:t>
+              <a:t>The raw results: </a:t>
             </a:r>
             <a:r>
               <a:rPr lang="en" sz="1300">
@@ -5645,7 +5645,7 @@
                 <a:cs typeface="Roboto"/>
                 <a:sym typeface="Roboto"/>
               </a:rPr>
-              <a:t>evidence/ holds the raw result files behind every number we quote.</a:t>
+              <a:t>evidence/ holds the file behind every number we quote.</a:t>
             </a:r>
           </a:p>
           <a:p>
@@ -5880,7 +5880,7 @@
                 <a:cs typeface="Roboto"/>
                 <a:sym typeface="Roboto"/>
               </a:rPr>
-              <a:t>ENACT’s policy operator names the best machine for an app, and keeps that answer current as the grid changes.</a:t>
+              <a:t>ENACT’s policy operator names the best machine for an app and keeps that answer current as the grid changes.</a:t>
             </a:r>
           </a:p>
           <a:p>
@@ -5904,7 +5904,7 @@
                 <a:cs typeface="Roboto"/>
                 <a:sym typeface="Roboto"/>
               </a:rPr>
-              <a:t>Nothing acts on the answer after deploy day. </a:t>
+              <a:t>After deploy day the app does not follow. </a:t>
             </a:r>
             <a:r>
               <a:rPr lang="en" sz="1300">
@@ -5913,7 +5913,7 @@
                 <a:cs typeface="Roboto"/>
                 <a:sym typeface="Roboto"/>
               </a:rPr>
-              <a:t>The SDK pins the app once. When its machine’s power turns dirty, GreenCharge stays there, breaking its own green rule.</a:t>
+              <a:t>The SDK pins it once, so when its machine’s power turns dirty, GreenCharge stays there, below its own 60% rule.</a:t>
             </a:r>
           </a:p>
           <a:p>
@@ -5937,7 +5937,7 @@
                 <a:cs typeface="Roboto"/>
                 <a:sym typeface="Roboto"/>
               </a:rPr>
-              <a:t>Sunflower is a small controller that carries out ENACT’s choice. </a:t>
+              <a:t>Sunflower is a small controller that reads ENACT’s choice and moves the app to it, </a:t>
             </a:r>
             <a:r>
               <a:rPr lang="en" sz="1300">
@@ -5946,7 +5946,7 @@
                 <a:cs typeface="Roboto"/>
                 <a:sym typeface="Roboto"/>
               </a:rPr>
-              <a:t>It moves the app when the choice changes and the change lasts, without losing a request. It never chooses a machine itself.</a:t>
+              <a:t>once the change has lasted, without losing a request.</a:t>
             </a:r>
           </a:p>
           <a:p>
@@ -5970,7 +5970,7 @@
                 <a:cs typeface="Roboto"/>
                 <a:sym typeface="Roboto"/>
               </a:rPr>
-              <a:t>We did the challenge checklist through the ENACT SDK, then built Sunflower on top of it.</a:t>
+              <a:t>We completed the challenge checklist in the ENACT SDK first, then built Sunflower on top.</a:t>
             </a:r>
           </a:p>
         </p:txBody>
@@ -6029,7 +6029,7 @@
       </p:sp>
       <p:pic>
         <p:nvPicPr>
-          <p:cNvPr id="201" name="Race screen" descr="Two copies of GreenCharge over one replayed day of grid data: the standard build stays put, the copy with Sunflower moves."/>
+          <p:cNvPr id="201" name="Race screen" descr="Two copies of GreenCharge over one replayed day of grid data: the standard build stays on Machine A, the copy with Sunflower moves to Machine B."/>
           <p:cNvPicPr>
             <a:picLocks noChangeAspect="1"/>
           </p:cNvPicPr>
@@ -6044,7 +6044,7 @@
         <p:spPr>
           <a:xfrm>
             <a:off x="4352000" y="1235000"/>
-            <a:ext cx="4480000" cy="2507555"/>
+            <a:ext cx="4480000" cy="2488888"/>
           </a:xfrm>
           <a:prstGeom prst="rect">
             <a:avLst/>
@@ -6064,7 +6064,7 @@
         </p:nvSpPr>
         <p:spPr>
           <a:xfrm>
-            <a:off x="4352000" y="3812555"/>
+            <a:off x="4352000" y="3793888"/>
             <a:ext cx="4480000" cy="420000"/>
           </a:xfrm>
           <a:prstGeom prst="rect">
@@ -6103,7 +6103,7 @@
                 <a:cs typeface="Roboto"/>
                 <a:sym typeface="Roboto"/>
               </a:rPr>
-              <a:t>One real run on the challenge cluster. Each stitch is a request, coloured by the machine that answered. Top lane: standard build. Bottom lane: with Sunflower.</a:t>
+              <a:t>One real run on the challenge cluster. Left: the standard build, 48 s on dirty power. Right: with Sunflower, 12 s. Each was sent 507 requests and lost none.</a:t>
             </a:r>
           </a:p>
         </p:txBody>
@@ -6229,7 +6229,7 @@
                 <a:cs typeface="Roboto"/>
                 <a:sym typeface="Roboto"/>
               </a:rPr>
-              <a:t>Checklist done through the ENACT SDK: </a:t>
+              <a:t>Checklist done in the ENACT SDK: </a:t>
             </a:r>
             <a:r>
               <a:rPr lang="en" sz="1200">
@@ -6238,7 +6238,7 @@
                 <a:cs typeface="Roboto"/>
                 <a:sym typeface="Roboto"/>
               </a:rPr>
-              <a:t>policy model, Application Controller extension (14 tests), policy, packaging, deployment and monitoring, plus one step with the AI assistant. Screenshot of every step in the repo.</a:t>
+              <a:t>policy model, Application Controller extension (14 tests), policy, packaging, deployment and monitoring, plus one step with the SDK’s assistant. The repo has a screenshot of every step.</a:t>
             </a:r>
           </a:p>
           <a:p>
@@ -6262,7 +6262,7 @@
                 <a:cs typeface="Roboto"/>
                 <a:sym typeface="Roboto"/>
               </a:rPr>
-              <a:t>Sunflower follows, it does not decide: </a:t>
+              <a:t>ENACT stays in charge: </a:t>
             </a:r>
             <a:r>
               <a:rPr lang="en" sz="1200">
@@ -6271,7 +6271,7 @@
                 <a:cs typeface="Roboto"/>
                 <a:sym typeface="Roboto"/>
               </a:rPr>
-              <a:t>one annotation opts an app in. It waits out short dips, ignores near-ties, limits how often it moves, and undoes a move that fails.</a:t>
+              <a:t>Sunflower reads the policy’s chosen machine and has no ranking of its own. It waits out short dips, ignores near-ties, limits how often it moves, and undoes a move that fails.</a:t>
             </a:r>
           </a:p>
           <a:p>
@@ -6295,7 +6295,7 @@
                 <a:cs typeface="Roboto"/>
                 <a:sym typeface="Roboto"/>
               </a:rPr>
-              <a:t>Honest about what is open: </a:t>
+              <a:t>Still open: </a:t>
             </a:r>
             <a:r>
               <a:rPr lang="en" sz="1200">
@@ -6304,7 +6304,7 @@
                 <a:cs typeface="Roboto"/>
                 <a:sym typeface="Roboto"/>
               </a:rPr>
-              <a:t>the dataspace step is waiting on connector details from the mentors, and we make no carbon-saving claim, only time out of policy, which we measured.</a:t>
+              <a:t>the dataspace step, which needs connector details we have asked the mentors for. We make no carbon-saving claim. We report time on dirty power, which we measured.</a:t>
             </a:r>
           </a:p>
         </p:txBody>
@@ -6460,7 +6460,7 @@
                 <a:cs typeface="Roboto"/>
                 <a:sym typeface="Roboto"/>
               </a:rPr>
-              <a:t>across 30 moves in a row, 2,632 requests, on the challenge cluster</a:t>
+              <a:t>across 30 moves in a row, 1,777 requests, on the challenge cluster</a:t>
             </a:r>
           </a:p>
         </p:txBody>
@@ -6512,7 +6512,7 @@
                 <a:cs typeface="Roboto"/>
                 <a:sym typeface="Roboto"/>
               </a:rPr>
-              <a:t>48 → 13 s</a:t>
+              <a:t>48 → 12 s</a:t>
             </a:r>
           </a:p>
           <a:p>
@@ -6538,7 +6538,7 @@
                 <a:cs typeface="Roboto"/>
                 <a:sym typeface="Roboto"/>
               </a:rPr>
-              <a:t>breaking its green rule</a:t>
+              <a:t>on dirty power</a:t>
             </a:r>
           </a:p>
           <a:p>
@@ -6564,7 +6564,7 @@
                 <a:cs typeface="Roboto"/>
                 <a:sym typeface="Roboto"/>
               </a:rPr>
-              <a:t>standard build against Sunflower, over a real day of British grid data</a:t>
+              <a:t>standard build against Sunflower, over a real day of British grid data: 6 hours against 1.5</a:t>
             </a:r>
           </a:p>
         </p:txBody>
@@ -6668,7 +6668,7 @@
                 <a:cs typeface="Roboto"/>
                 <a:sym typeface="Roboto"/>
               </a:rPr>
-              <a:t>ENACT rough edges we hit, each written up with the fix we used</a:t>
+              <a:t>problems we hit in ENACT, each written up with the fix we used</a:t>
             </a:r>
           </a:p>
         </p:txBody>

</xml_diff>

<commit_message>
Show where Sunflower's 12 seconds go: the measured wait and the move, on the screen and in the slides, README and pitch
</commit_message>
<xml_diff>
--- a/docs/slides/Sunflower-VelesHack.pptx
+++ b/docs/slides/Sunflower-VelesHack.pptx
@@ -6192,8 +6192,8 @@
         </p:nvSpPr>
         <p:spPr>
           <a:xfrm>
-            <a:off x="311700" y="2700000"/>
-            <a:ext cx="8520600" cy="1900000"/>
+            <a:off x="311700" y="2560000"/>
+            <a:ext cx="8520600" cy="2060000"/>
           </a:xfrm>
           <a:prstGeom prst="rect">
             <a:avLst/>
@@ -6217,7 +6217,40 @@
                 <a:spcPts val="0"/>
               </a:spcBef>
               <a:spcAft>
-                <a:spcPts val="400"/>
+                <a:spcPts val="300"/>
+              </a:spcAft>
+              <a:buSzPts val="1300"/>
+              <a:buChar char="●"/>
+            </a:pPr>
+            <a:r>
+              <a:rPr lang="en" sz="1200" b="1">
+                <a:latin typeface="Roboto"/>
+                <a:ea typeface="Roboto"/>
+                <a:cs typeface="Roboto"/>
+                <a:sym typeface="Roboto"/>
+              </a:rPr>
+              <a:t>Where the 12 s go: </a:t>
+            </a:r>
+            <a:r>
+              <a:rPr lang="en" sz="1200">
+                <a:latin typeface="Roboto"/>
+                <a:ea typeface="Roboto"/>
+                <a:cs typeface="Roboto"/>
+                <a:sym typeface="Roboto"/>
+              </a:rPr>
+              <a:t>8 s is a deliberate wait to be sure the drop is real (a setting), and 3.5 s is the move. Both copies answer every request throughout.</a:t>
+            </a:r>
+          </a:p>
+          <a:p>
+            <a:pPr indent="-285750" marL="342900" lvl="0" rtl="0" algn="l">
+              <a:lnSpc>
+                <a:spcPct val="110000"/>
+              </a:lnSpc>
+              <a:spcBef>
+                <a:spcPts val="0"/>
+              </a:spcBef>
+              <a:spcAft>
+                <a:spcPts val="300"/>
               </a:spcAft>
               <a:buSzPts val="1300"/>
               <a:buChar char="●"/>
@@ -6250,7 +6283,7 @@
                 <a:spcPts val="0"/>
               </a:spcBef>
               <a:spcAft>
-                <a:spcPts val="400"/>
+                <a:spcPts val="300"/>
               </a:spcAft>
               <a:buSzPts val="1300"/>
               <a:buChar char="●"/>

</xml_diff>

<commit_message>
State the real-speed comparison correctly: 6 hours against about 24 seconds
The standard build's replayed seconds scale back up to hours because a dirty stretch lasts as
long as the grid makes it. Sunflower's wait and move do not stretch with the day, so its
replayed 12 seconds are not 1.5 hours: at real speed it is the default 20 s wait plus the
measured move. The screen, README, slides, pitch and question sheet now say so, and mark
the 24 seconds as worked out from measurements.
</commit_message>
<xml_diff>
--- a/docs/slides/Sunflower-VelesHack.pptx
+++ b/docs/slides/Sunflower-VelesHack.pptx
@@ -6238,7 +6238,7 @@
                 <a:cs typeface="Roboto"/>
                 <a:sym typeface="Roboto"/>
               </a:rPr>
-              <a:t>8 s is a deliberate wait to be sure the drop is real (a setting), and 3.5 s is the move. Both copies answer every request throughout.</a:t>
+              <a:t>8 s is a deliberate wait to be sure the drop is real, and 3.5 s is the move. Neither stretches with the day, so at real speed (default wait 20 s) Sunflower is on dirty power for about 24 seconds while the standard build sits through 6 hours.</a:t>
             </a:r>
           </a:p>
           <a:p>
@@ -6597,7 +6597,7 @@
                 <a:cs typeface="Roboto"/>
                 <a:sym typeface="Roboto"/>
               </a:rPr>
-              <a:t>standard build against Sunflower, over a real day of British grid data: 6 hours against 1.5</a:t>
+              <a:t>in the replay. At real speed: 6 hours for the standard build, about 24 seconds with Sunflower</a:t>
             </a:r>
           </a:p>
         </p:txBody>

</xml_diff>

<commit_message>
Connect the ENACT dataspace: GreenCharge now reads the transferred carbon-intensity asset
Done through the SDK's Dataspaces module (screenshots 23 to 32): consumer connector added,
grid-carbon-intensity found in the provider's catalogue, contract negotiated, file transferred
and saved unedited under greencharge/dataspace. application.yml points at it for local runs
and the scene scripts mount it into both copies, whose badge now reads "live (dataspace
file)". Four findings from the step are added to the field report, and the README, slides,
pitch and question sheet no longer list it as open.
</commit_message>
<xml_diff>
--- a/docs/slides/Sunflower-VelesHack.pptx
+++ b/docs/slides/Sunflower-VelesHack.pptx
@@ -5678,7 +5678,7 @@
                 <a:cs typeface="Roboto"/>
                 <a:sym typeface="Roboto"/>
               </a:rPr>
-              <a:t>docs/field-report.md, 39 findings, each with the fix we used.</a:t>
+              <a:t>docs/field-report.md, 44 findings, each with the fix we used.</a:t>
             </a:r>
           </a:p>
           <a:p>
@@ -5970,7 +5970,7 @@
                 <a:cs typeface="Roboto"/>
                 <a:sym typeface="Roboto"/>
               </a:rPr>
-              <a:t>We completed the challenge checklist in the ENACT SDK first, then built Sunflower on top.</a:t>
+              <a:t>We completed all five items of the challenge checklist in the ENACT SDK, dataspace included, then built Sunflower on top.</a:t>
             </a:r>
           </a:p>
         </p:txBody>
@@ -6271,7 +6271,7 @@
                 <a:cs typeface="Roboto"/>
                 <a:sym typeface="Roboto"/>
               </a:rPr>
-              <a:t>policy model, Application Controller extension (14 tests), policy, packaging, deployment and monitoring, plus one step with the SDK’s assistant. The repo has a screenshot of every step.</a:t>
+              <a:t>dataspace feed, policy model, Application Controller extension (14 tests), policy, packaging, deployment and monitoring, plus one step with the SDK’s assistant. The repo has a screenshot of every step.</a:t>
             </a:r>
           </a:p>
           <a:p>
@@ -6328,7 +6328,7 @@
                 <a:cs typeface="Roboto"/>
                 <a:sym typeface="Roboto"/>
               </a:rPr>
-              <a:t>Still open: </a:t>
+              <a:t>What we do not claim: </a:t>
             </a:r>
             <a:r>
               <a:rPr lang="en" sz="1200">
@@ -6337,7 +6337,7 @@
                 <a:cs typeface="Roboto"/>
                 <a:sym typeface="Roboto"/>
               </a:rPr>
-              <a:t>the dataspace step, which needs connector details we have asked the mentors for. We make no carbon-saving claim. We report time on dirty power, which we measured.</a:t>
+              <a:t>carbon saved. This cluster reports energy as a model estimate, so we report time on dirty power, which we measured.</a:t>
             </a:r>
           </a:p>
         </p:txBody>
@@ -6649,7 +6649,7 @@
                 <a:cs typeface="Roboto"/>
                 <a:sym typeface="Roboto"/>
               </a:rPr>
-              <a:t>39</a:t>
+              <a:t>44</a:t>
             </a:r>
           </a:p>
           <a:p>

</xml_diff>

<commit_message>
Deploy through the SDK onto enact-dev-worker, and record that it cannot deploy a Helm chart yet
</commit_message>
<xml_diff>
--- a/docs/slides/Sunflower-VelesHack.pptx
+++ b/docs/slides/Sunflower-VelesHack.pptx
@@ -5678,7 +5678,7 @@
                 <a:cs typeface="Roboto"/>
                 <a:sym typeface="Roboto"/>
               </a:rPr>
-              <a:t>docs/field-report.md, 44 findings, each with the fix we used.</a:t>
+              <a:t>docs/field-report.md, 45 findings, each with the fix we used.</a:t>
             </a:r>
           </a:p>
           <a:p>
@@ -6649,7 +6649,7 @@
                 <a:cs typeface="Roboto"/>
                 <a:sym typeface="Roboto"/>
               </a:rPr>
-              <a:t>44</a:t>
+              <a:t>45</a:t>
             </a:r>
           </a:p>
           <a:p>

</xml_diff>

<commit_message>
Lead with the real-speed comparison: 6 hours against about 24 seconds
The screen's big number on each panel is now time on dirty power at real speed, counted up
live from the run's own log, with the replay seconds beneath it. The README, slides, pitch
and question sheet explain why 48 s against 12 s in the replay is not a four-to-one result.
</commit_message>
<xml_diff>
--- a/docs/slides/Sunflower-VelesHack.pptx
+++ b/docs/slides/Sunflower-VelesHack.pptx
@@ -6103,7 +6103,7 @@
                 <a:cs typeface="Roboto"/>
                 <a:sym typeface="Roboto"/>
               </a:rPr>
-              <a:t>One real run on the challenge cluster. Left: the standard build, 48 s on dirty power. Right: with Sunflower, 12 s. Each was sent 507 requests and lost none.</a:t>
+              <a:t>One real run on the challenge cluster. Left: the standard build, 6 hours on dirty power at real speed. Right: with Sunflower, about 24 seconds. Each was sent 507 requests and lost none.</a:t>
             </a:r>
           </a:p>
         </p:txBody>
@@ -6229,7 +6229,7 @@
                 <a:cs typeface="Roboto"/>
                 <a:sym typeface="Roboto"/>
               </a:rPr>
-              <a:t>Where the 12 s go: </a:t>
+              <a:t>How we get 6 hours against 24 seconds: </a:t>
             </a:r>
             <a:r>
               <a:rPr lang="en" sz="1200">
@@ -6238,7 +6238,7 @@
                 <a:cs typeface="Roboto"/>
                 <a:sym typeface="Roboto"/>
               </a:rPr>
-              <a:t>8 s is a deliberate wait to be sure the drop is real, and 3.5 s is the move. Neither stretches with the day, so at real speed (default wait 20 s) Sunflower is on dirty power for about 24 seconds while the standard build sits through 6 hours.</a:t>
+              <a:t>our replay runs the day 450 times faster and shows 48 s against 12 s. The standard build’s 48 s are the whole dirty stretch, which is 6 hours at real speed. Sunflower’s 12 s are a wait and a 3.5 s move that do not stretch with the day: with its default 20 s wait, about 24 seconds.</a:t>
             </a:r>
           </a:p>
           <a:p>
@@ -6545,7 +6545,7 @@
                 <a:cs typeface="Roboto"/>
                 <a:sym typeface="Roboto"/>
               </a:rPr>
-              <a:t>48 → 12 s</a:t>
+              <a:t>6 h → 24 s</a:t>
             </a:r>
           </a:p>
           <a:p>
@@ -6571,7 +6571,7 @@
                 <a:cs typeface="Roboto"/>
                 <a:sym typeface="Roboto"/>
               </a:rPr>
-              <a:t>on dirty power</a:t>
+              <a:t>on dirty power, at real speed</a:t>
             </a:r>
           </a:p>
           <a:p>
@@ -6597,7 +6597,7 @@
                 <a:cs typeface="Roboto"/>
                 <a:sym typeface="Roboto"/>
               </a:rPr>
-              <a:t>in the replay. At real speed: 6 hours for the standard build, about 24 seconds with Sunflower</a:t>
+              <a:t>standard build against Sunflower, over a real day of British grid data</a:t>
             </a:r>
           </a:p>
         </p:txBody>

</xml_diff>

<commit_message>
Write the README, pitch, questions, report and slides in the first person singular
</commit_message>
<xml_diff>
--- a/docs/slides/Sunflower-VelesHack.pptx
+++ b/docs/slides/Sunflower-VelesHack.pptx
@@ -5645,7 +5645,7 @@
                 <a:cs typeface="Roboto"/>
                 <a:sym typeface="Roboto"/>
               </a:rPr>
-              <a:t>evidence/ holds the file behind every number we quote.</a:t>
+              <a:t>evidence/ holds the file behind every number I quote.</a:t>
             </a:r>
           </a:p>
           <a:p>
@@ -5669,7 +5669,7 @@
                 <a:cs typeface="Roboto"/>
                 <a:sym typeface="Roboto"/>
               </a:rPr>
-              <a:t>What we are giving back to ENACT: </a:t>
+              <a:t>What I am giving back to ENACT: </a:t>
             </a:r>
             <a:r>
               <a:rPr lang="en" sz="1300">
@@ -5678,7 +5678,7 @@
                 <a:cs typeface="Roboto"/>
                 <a:sym typeface="Roboto"/>
               </a:rPr>
-              <a:t>docs/field-report.md, 45 findings, each with the fix we used.</a:t>
+              <a:t>docs/field-report.md, 45 findings, each with the fix I used.</a:t>
             </a:r>
           </a:p>
           <a:p>
@@ -5970,7 +5970,7 @@
                 <a:cs typeface="Roboto"/>
                 <a:sym typeface="Roboto"/>
               </a:rPr>
-              <a:t>We completed all five items of the challenge checklist in the ENACT SDK, dataspace included, then built Sunflower on top.</a:t>
+              <a:t>I completed all five items of the challenge checklist in the ENACT SDK, dataspace included, then built Sunflower on top.</a:t>
             </a:r>
           </a:p>
         </p:txBody>
@@ -6229,7 +6229,7 @@
                 <a:cs typeface="Roboto"/>
                 <a:sym typeface="Roboto"/>
               </a:rPr>
-              <a:t>How we get 6 hours against 24 seconds: </a:t>
+              <a:t>How I get 6 hours against 24 seconds: </a:t>
             </a:r>
             <a:r>
               <a:rPr lang="en" sz="1200">
@@ -6238,7 +6238,7 @@
                 <a:cs typeface="Roboto"/>
                 <a:sym typeface="Roboto"/>
               </a:rPr>
-              <a:t>our replay runs the day 450 times faster and shows 48 s against 12 s. The standard build’s 48 s are the whole dirty stretch, which is 6 hours at real speed. Sunflower’s 12 s are a wait and a 3.5 s move that do not stretch with the day: with its default 20 s wait, about 24 seconds.</a:t>
+              <a:t>my replay runs the day 450 times faster and shows 48 s against 12 s. The standard build’s 48 s are the whole dirty stretch, which is 6 hours at real speed. Sunflower’s 12 s are a wait and a 3.5 s move that do not stretch with the day: with its default 20 s wait, about 24 seconds.</a:t>
             </a:r>
           </a:p>
           <a:p>
@@ -6328,7 +6328,7 @@
                 <a:cs typeface="Roboto"/>
                 <a:sym typeface="Roboto"/>
               </a:rPr>
-              <a:t>What we do not claim: </a:t>
+              <a:t>What I do not claim: </a:t>
             </a:r>
             <a:r>
               <a:rPr lang="en" sz="1200">
@@ -6337,7 +6337,7 @@
                 <a:cs typeface="Roboto"/>
                 <a:sym typeface="Roboto"/>
               </a:rPr>
-              <a:t>carbon saved. This cluster reports energy as a model estimate, so we report time on dirty power, which we measured.</a:t>
+              <a:t>carbon saved. This cluster reports energy as a model estimate, so I report time on dirty power, which I measured.</a:t>
             </a:r>
           </a:p>
         </p:txBody>
@@ -6701,7 +6701,7 @@
                 <a:cs typeface="Roboto"/>
                 <a:sym typeface="Roboto"/>
               </a:rPr>
-              <a:t>problems we hit in ENACT, each written up with the fix we used</a:t>
+              <a:t>problems I hit in ENACT, each written up with the fix I used</a:t>
             </a:r>
           </a:p>
         </p:txBody>

</xml_diff>

<commit_message>
Drop the line on carbon from the Highlights slide
</commit_message>
<xml_diff>
--- a/docs/slides/Sunflower-VelesHack.pptx
+++ b/docs/slides/Sunflower-VelesHack.pptx
@@ -6307,39 +6307,6 @@
               <a:t>Sunflower reads the policy’s chosen machine and has no ranking of its own. It waits out short dips, ignores near-ties, limits how often it moves, and undoes a move that fails.</a:t>
             </a:r>
           </a:p>
-          <a:p>
-            <a:pPr indent="-285750" marL="342900" lvl="0" rtl="0" algn="l">
-              <a:lnSpc>
-                <a:spcPct val="110000"/>
-              </a:lnSpc>
-              <a:spcBef>
-                <a:spcPts val="0"/>
-              </a:spcBef>
-              <a:spcAft>
-                <a:spcPts val="0"/>
-              </a:spcAft>
-              <a:buSzPts val="1300"/>
-              <a:buChar char="●"/>
-            </a:pPr>
-            <a:r>
-              <a:rPr lang="en" sz="1200" b="1">
-                <a:latin typeface="Roboto"/>
-                <a:ea typeface="Roboto"/>
-                <a:cs typeface="Roboto"/>
-                <a:sym typeface="Roboto"/>
-              </a:rPr>
-              <a:t>What I do not claim: </a:t>
-            </a:r>
-            <a:r>
-              <a:rPr lang="en" sz="1200">
-                <a:latin typeface="Roboto"/>
-                <a:ea typeface="Roboto"/>
-                <a:cs typeface="Roboto"/>
-                <a:sym typeface="Roboto"/>
-              </a:rPr>
-              <a:t>carbon saved. This cluster reports energy as a model estimate, so I report time on dirty power, which I measured.</a:t>
-            </a:r>
-          </a:p>
         </p:txBody>
       </p:sp>
       <p:sp>

</xml_diff>